<commit_message>
style: remove evaluation metrics from slide 1 and apply clean minimalist cover
</commit_message>
<xml_diff>
--- a/docs/QA_AI_Assistant_Interview_Presentation.pptx
+++ b/docs/QA_AI_Assistant_Interview_Presentation.pptx
@@ -3193,8 +3193,8 @@
         </p:nvSpPr>
         <p:spPr>
           <a:xfrm>
-            <a:off x="731520" y="502920"/>
-            <a:ext cx="10698480" cy="1645920"/>
+            <a:off x="1097280" y="1828800"/>
+            <a:ext cx="9997135" cy="2743200"/>
           </a:xfrm>
           <a:prstGeom prst="rect">
             <a:avLst/>
@@ -3207,11 +3207,11 @@
           </a:bodyPr>
           <a:lstStyle/>
           <a:p>
-            <a:pPr>
-              <a:spcAft>
-                <a:spcPts val="400"/>
-              </a:spcAft>
-              <a:defRPr sz="1050" b="1">
+            <a:pPr algn="ctr">
+              <a:spcAft>
+                <a:spcPts val="1200"/>
+              </a:spcAft>
+              <a:defRPr sz="1200" b="1">
                 <a:solidFill>
                   <a:srgbClr val="0958D9"/>
                 </a:solidFill>
@@ -3222,11 +3222,11 @@
             </a:r>
           </a:p>
           <a:p>
-            <a:pPr>
-              <a:spcAft>
-                <a:spcPts val="400"/>
-              </a:spcAft>
-              <a:defRPr sz="2400" b="1">
+            <a:pPr algn="ctr">
+              <a:spcAft>
+                <a:spcPts val="1400"/>
+              </a:spcAft>
+              <a:defRPr sz="3000" b="1">
                 <a:solidFill>
                   <a:srgbClr val="1E293B"/>
                 </a:solidFill>
@@ -3241,8 +3241,8 @@
             </a:r>
           </a:p>
           <a:p>
-            <a:pPr>
-              <a:defRPr sz="1200">
+            <a:pPr algn="ctr">
+              <a:defRPr sz="1350">
                 <a:solidFill>
                   <a:srgbClr val="64748B"/>
                 </a:solidFill>
@@ -3262,8 +3262,8 @@
         </p:nvSpPr>
         <p:spPr>
           <a:xfrm>
-            <a:off x="731520" y="2331720"/>
-            <a:ext cx="10698480" cy="2377440"/>
+            <a:off x="2011680" y="4846320"/>
+            <a:ext cx="8168335" cy="685800"/>
           </a:xfrm>
           <a:prstGeom prst="roundRect">
             <a:avLst/>
@@ -3271,9 +3271,9 @@
           <a:solidFill>
             <a:srgbClr val="FFFFFF"/>
           </a:solidFill>
-          <a:ln w="19050">
+          <a:ln w="12700">
             <a:solidFill>
-              <a:srgbClr val="CBD5E1"/>
+              <a:srgbClr val="E2E8F0"/>
             </a:solidFill>
           </a:ln>
         </p:spPr>
@@ -3292,477 +3292,18 @@
           </a:fontRef>
         </p:style>
         <p:txBody>
-          <a:bodyPr rtlCol="0" anchor="ctr"/>
-          <a:lstStyle/>
-          <a:p>
-            <a:pPr algn="ctr"/>
-          </a:p>
-        </p:txBody>
-      </p:sp>
-      <p:sp>
-        <p:nvSpPr>
-          <p:cNvPr id="6" name="Rounded Rectangle 5"/>
-          <p:cNvSpPr/>
-          <p:nvPr/>
-        </p:nvSpPr>
-        <p:spPr>
-          <a:xfrm>
-            <a:off x="914400" y="2514600"/>
-            <a:ext cx="5029200" cy="2011680"/>
-          </a:xfrm>
-          <a:prstGeom prst="roundRect">
-            <a:avLst/>
-          </a:prstGeom>
-          <a:solidFill>
-            <a:srgbClr val="E6F4FF"/>
-          </a:solidFill>
-          <a:ln w="19050">
-            <a:solidFill>
-              <a:srgbClr val="1677FF"/>
-            </a:solidFill>
-          </a:ln>
-        </p:spPr>
-        <p:style>
-          <a:lnRef idx="1">
-            <a:schemeClr val="accent1"/>
-          </a:lnRef>
-          <a:fillRef idx="3">
-            <a:schemeClr val="accent1"/>
-          </a:fillRef>
-          <a:effectRef idx="2">
-            <a:schemeClr val="accent1"/>
-          </a:effectRef>
-          <a:fontRef idx="minor">
-            <a:schemeClr val="lt1"/>
-          </a:fontRef>
-        </p:style>
-        <p:txBody>
           <a:bodyPr rtlCol="0" anchor="ctr" wrap="square"/>
           <a:lstStyle/>
           <a:p>
             <a:pPr algn="ctr">
-              <a:spcAft>
-                <a:spcPts val="600"/>
-              </a:spcAft>
               <a:defRPr sz="1100" b="1">
                 <a:solidFill>
-                  <a:srgbClr val="0958D9"/>
-                </a:solidFill>
-              </a:defRPr>
-            </a:pPr>
-            <a:r>
-              <a:t>🤖 HỆ THỐNG ĐANG LÀM GÌ? (WHAT IT DOES)</a:t>
-            </a:r>
-          </a:p>
-          <a:p>
-            <a:pPr>
-              <a:spcAft>
-                <a:spcPts val="300"/>
-              </a:spcAft>
-              <a:defRPr sz="950">
-                <a:solidFill>
                   <a:srgbClr val="1E293B"/>
                 </a:solidFill>
               </a:defRPr>
             </a:pPr>
             <a:r>
-              <a:t>• Tiếp nhận tài liệu thô: User Story, PRD, API Swagger chưa rõ nét hoặc thiếu kịch bản biên.</a:t>
-            </a:r>
-          </a:p>
-          <a:p>
-            <a:pPr>
-              <a:spcAft>
-                <a:spcPts val="300"/>
-              </a:spcAft>
-              <a:defRPr sz="950">
-                <a:solidFill>
-                  <a:srgbClr val="1E293B"/>
-                </a:solidFill>
-              </a:defRPr>
-            </a:pPr>
-            <a:r>
-              <a:t>• Bóc tách 4 thành tố: Tự động phân tách Business Rules, Boundary Limits, Exceptions &amp; User Flow.</a:t>
-            </a:r>
-          </a:p>
-          <a:p>
-            <a:pPr>
-              <a:spcAft>
-                <a:spcPts val="300"/>
-              </a:spcAft>
-              <a:defRPr sz="950">
-                <a:solidFill>
-                  <a:srgbClr val="1E293B"/>
-                </a:solidFill>
-              </a:defRPr>
-            </a:pPr>
-            <a:r>
-              <a:t>• Quét 5 rủi ro kiến trúc: Phát hiện lỗi ngầm: Concurrency (&lt;=50ms), Lost Update, Deadlock, JWT Drift.</a:t>
-            </a:r>
-          </a:p>
-          <a:p>
-            <a:pPr>
-              <a:spcAft>
-                <a:spcPts val="300"/>
-              </a:spcAft>
-              <a:defRPr sz="950">
-                <a:solidFill>
-                  <a:srgbClr val="1E293B"/>
-                </a:solidFill>
-              </a:defRPr>
-            </a:pPr>
-            <a:r>
-              <a:t>• Thiết kế Test 3 tầng sâu: Sinh kịch bản tách bước kiểm chứng UI + API Body + DB &amp; Sync Google Sheets.</a:t>
-            </a:r>
-          </a:p>
-        </p:txBody>
-      </p:sp>
-      <p:sp>
-        <p:nvSpPr>
-          <p:cNvPr id="7" name="Rounded Rectangle 6"/>
-          <p:cNvSpPr/>
-          <p:nvPr/>
-        </p:nvSpPr>
-        <p:spPr>
-          <a:xfrm>
-            <a:off x="6217920" y="2514600"/>
-            <a:ext cx="5029200" cy="2011680"/>
-          </a:xfrm>
-          <a:prstGeom prst="roundRect">
-            <a:avLst/>
-          </a:prstGeom>
-          <a:solidFill>
-            <a:srgbClr val="DCFCE7"/>
-          </a:solidFill>
-          <a:ln w="19050">
-            <a:solidFill>
-              <a:srgbClr val="16A34A"/>
-            </a:solidFill>
-          </a:ln>
-        </p:spPr>
-        <p:style>
-          <a:lnRef idx="1">
-            <a:schemeClr val="accent1"/>
-          </a:lnRef>
-          <a:fillRef idx="3">
-            <a:schemeClr val="accent1"/>
-          </a:fillRef>
-          <a:effectRef idx="2">
-            <a:schemeClr val="accent1"/>
-          </a:effectRef>
-          <a:fontRef idx="minor">
-            <a:schemeClr val="lt1"/>
-          </a:fontRef>
-        </p:style>
-        <p:txBody>
-          <a:bodyPr rtlCol="0" anchor="ctr" wrap="square"/>
-          <a:lstStyle/>
-          <a:p>
-            <a:pPr algn="ctr">
-              <a:spcAft>
-                <a:spcPts val="600"/>
-              </a:spcAft>
-              <a:defRPr sz="1100" b="1">
-                <a:solidFill>
-                  <a:srgbClr val="15803D"/>
-                </a:solidFill>
-              </a:defRPr>
-            </a:pPr>
-            <a:r>
-              <a:t>🎯 NHIỆM VỤ TRỌNG TÂM CỦA HỆ THỐNG (SYSTEM MISSIONS)</a:t>
-            </a:r>
-          </a:p>
-          <a:p>
-            <a:pPr>
-              <a:spcAft>
-                <a:spcPts val="300"/>
-              </a:spcAft>
-              <a:defRPr sz="950">
-                <a:solidFill>
-                  <a:srgbClr val="1E293B"/>
-                </a:solidFill>
-              </a:defRPr>
-            </a:pPr>
-            <a:r>
-              <a:t>• Shift-Left QA: Chặn đứng 50% lỗi ngay từ khâu phân tích yêu cầu trước khi Dev code.</a:t>
-            </a:r>
-          </a:p>
-          <a:p>
-            <a:pPr>
-              <a:spcAft>
-                <a:spcPts val="300"/>
-              </a:spcAft>
-              <a:defRPr sz="950">
-                <a:solidFill>
-                  <a:srgbClr val="1E293B"/>
-                </a:solidFill>
-              </a:defRPr>
-            </a:pPr>
-            <a:r>
-              <a:t>• Giải phóng thao tác thủ công: Tự động hóa toàn diện khâu đọc hiểu tài liệu và soạn đặc tả kịch bản.</a:t>
-            </a:r>
-          </a:p>
-          <a:p>
-            <a:pPr>
-              <a:spcAft>
-                <a:spcPts val="300"/>
-              </a:spcAft>
-              <a:defRPr sz="950">
-                <a:solidFill>
-                  <a:srgbClr val="1E293B"/>
-                </a:solidFill>
-              </a:defRPr>
-            </a:pPr>
-            <a:r>
-              <a:t>• Triệt tiêu 100% ảo giác: Ép AI bám sát 10 bugs production thực tế, Tester phê duyệt qua 2 cổng.</a:t>
-            </a:r>
-          </a:p>
-          <a:p>
-            <a:pPr>
-              <a:spcAft>
-                <a:spcPts val="300"/>
-              </a:spcAft>
-              <a:defRPr sz="950">
-                <a:solidFill>
-                  <a:srgbClr val="1E293B"/>
-                </a:solidFill>
-              </a:defRPr>
-            </a:pPr>
-            <a:r>
-              <a:t>• Chuẩn hóa tài sản kiểm thử: Lưu trữ tích lũy bền vững và làm bệ phóng trực tiếp cho Playwright E2E.</a:t>
-            </a:r>
-          </a:p>
-        </p:txBody>
-      </p:sp>
-      <p:sp>
-        <p:nvSpPr>
-          <p:cNvPr id="8" name="Rounded Rectangle 7"/>
-          <p:cNvSpPr/>
-          <p:nvPr/>
-        </p:nvSpPr>
-        <p:spPr>
-          <a:xfrm>
-            <a:off x="731520" y="4892040"/>
-            <a:ext cx="3383280" cy="1371600"/>
-          </a:xfrm>
-          <a:prstGeom prst="roundRect">
-            <a:avLst/>
-          </a:prstGeom>
-          <a:solidFill>
-            <a:srgbClr val="FFFFFF"/>
-          </a:solidFill>
-          <a:ln w="19050">
-            <a:solidFill>
-              <a:srgbClr val="CBD5E1"/>
-            </a:solidFill>
-          </a:ln>
-        </p:spPr>
-        <p:style>
-          <a:lnRef idx="1">
-            <a:schemeClr val="accent1"/>
-          </a:lnRef>
-          <a:fillRef idx="3">
-            <a:schemeClr val="accent1"/>
-          </a:fillRef>
-          <a:effectRef idx="2">
-            <a:schemeClr val="accent1"/>
-          </a:effectRef>
-          <a:fontRef idx="minor">
-            <a:schemeClr val="lt1"/>
-          </a:fontRef>
-        </p:style>
-        <p:txBody>
-          <a:bodyPr rtlCol="0" anchor="ctr" wrap="square"/>
-          <a:lstStyle/>
-          <a:p>
-            <a:pPr algn="ctr">
-              <a:defRPr sz="950" b="1">
-                <a:solidFill>
-                  <a:srgbClr val="1677FF"/>
-                </a:solidFill>
-              </a:defRPr>
-            </a:pPr>
-            <a:r>
-              <a:t>🎯 ĐỘ CHÍNH XÁC DỮ LIỆU</a:t>
-            </a:r>
-          </a:p>
-          <a:p>
-            <a:pPr>
-              <a:defRPr sz="1800" b="1">
-                <a:solidFill>
-                  <a:srgbClr val="1E293B"/>
-                </a:solidFill>
-              </a:defRPr>
-            </a:pPr>
-            <a:r>
-              <a:t>≥ 92%</a:t>
-            </a:r>
-          </a:p>
-          <a:p>
-            <a:pPr>
-              <a:defRPr sz="950">
-                <a:solidFill>
-                  <a:srgbClr val="64748B"/>
-                </a:solidFill>
-              </a:defRPr>
-            </a:pPr>
-            <a:r>
-              <a:t>Kiểm chứng sâu 3 tầng, 0 ảo giác</a:t>
-            </a:r>
-          </a:p>
-        </p:txBody>
-      </p:sp>
-      <p:sp>
-        <p:nvSpPr>
-          <p:cNvPr id="9" name="Rounded Rectangle 8"/>
-          <p:cNvSpPr/>
-          <p:nvPr/>
-        </p:nvSpPr>
-        <p:spPr>
-          <a:xfrm>
-            <a:off x="4389120" y="4892040"/>
-            <a:ext cx="3383280" cy="1371600"/>
-          </a:xfrm>
-          <a:prstGeom prst="roundRect">
-            <a:avLst/>
-          </a:prstGeom>
-          <a:solidFill>
-            <a:srgbClr val="FFFFFF"/>
-          </a:solidFill>
-          <a:ln w="19050">
-            <a:solidFill>
-              <a:srgbClr val="CBD5E1"/>
-            </a:solidFill>
-          </a:ln>
-        </p:spPr>
-        <p:style>
-          <a:lnRef idx="1">
-            <a:schemeClr val="accent1"/>
-          </a:lnRef>
-          <a:fillRef idx="3">
-            <a:schemeClr val="accent1"/>
-          </a:fillRef>
-          <a:effectRef idx="2">
-            <a:schemeClr val="accent1"/>
-          </a:effectRef>
-          <a:fontRef idx="minor">
-            <a:schemeClr val="lt1"/>
-          </a:fontRef>
-        </p:style>
-        <p:txBody>
-          <a:bodyPr rtlCol="0" anchor="ctr" wrap="square"/>
-          <a:lstStyle/>
-          <a:p>
-            <a:pPr algn="ctr">
-              <a:defRPr sz="950" b="1">
-                <a:solidFill>
-                  <a:srgbClr val="16A34A"/>
-                </a:solidFill>
-              </a:defRPr>
-            </a:pPr>
-            <a:r>
-              <a:t>🛡️ CHẤT LƯỢNG RELEASE</a:t>
-            </a:r>
-          </a:p>
-          <a:p>
-            <a:pPr>
-              <a:defRPr sz="1800" b="1">
-                <a:solidFill>
-                  <a:srgbClr val="1E293B"/>
-                </a:solidFill>
-              </a:defRPr>
-            </a:pPr>
-            <a:r>
-              <a:t>Giảm 50% Defect</a:t>
-            </a:r>
-          </a:p>
-          <a:p>
-            <a:pPr>
-              <a:defRPr sz="950">
-                <a:solidFill>
-                  <a:srgbClr val="64748B"/>
-                </a:solidFill>
-              </a:defRPr>
-            </a:pPr>
-            <a:r>
-              <a:t>Chặn đứng lỗi sớm ngay khâu Spec</a:t>
-            </a:r>
-          </a:p>
-        </p:txBody>
-      </p:sp>
-      <p:sp>
-        <p:nvSpPr>
-          <p:cNvPr id="10" name="Rounded Rectangle 9"/>
-          <p:cNvSpPr/>
-          <p:nvPr/>
-        </p:nvSpPr>
-        <p:spPr>
-          <a:xfrm>
-            <a:off x="8046720" y="4892040"/>
-            <a:ext cx="3383280" cy="1371600"/>
-          </a:xfrm>
-          <a:prstGeom prst="roundRect">
-            <a:avLst/>
-          </a:prstGeom>
-          <a:solidFill>
-            <a:srgbClr val="FFFFFF"/>
-          </a:solidFill>
-          <a:ln w="19050">
-            <a:solidFill>
-              <a:srgbClr val="CBD5E1"/>
-            </a:solidFill>
-          </a:ln>
-        </p:spPr>
-        <p:style>
-          <a:lnRef idx="1">
-            <a:schemeClr val="accent1"/>
-          </a:lnRef>
-          <a:fillRef idx="3">
-            <a:schemeClr val="accent1"/>
-          </a:fillRef>
-          <a:effectRef idx="2">
-            <a:schemeClr val="accent1"/>
-          </a:effectRef>
-          <a:fontRef idx="minor">
-            <a:schemeClr val="lt1"/>
-          </a:fontRef>
-        </p:style>
-        <p:txBody>
-          <a:bodyPr rtlCol="0" anchor="ctr" wrap="square"/>
-          <a:lstStyle/>
-          <a:p>
-            <a:pPr algn="ctr">
-              <a:defRPr sz="950" b="1">
-                <a:solidFill>
-                  <a:srgbClr val="D97706"/>
-                </a:solidFill>
-              </a:defRPr>
-            </a:pPr>
-            <a:r>
-              <a:t>⚡ TỰ ĐỘNG HÓA QUY TRÌNH</a:t>
-            </a:r>
-          </a:p>
-          <a:p>
-            <a:pPr>
-              <a:defRPr sz="1800" b="1">
-                <a:solidFill>
-                  <a:srgbClr val="1E293B"/>
-                </a:solidFill>
-              </a:defRPr>
-            </a:pPr>
-            <a:r>
-              <a:t>80% Tác Vụ</a:t>
-            </a:r>
-          </a:p>
-          <a:p>
-            <a:pPr>
-              <a:defRPr sz="950">
-                <a:solidFill>
-                  <a:srgbClr val="64748B"/>
-                </a:solidFill>
-              </a:defRPr>
-            </a:pPr>
-            <a:r>
-              <a:t>Tự động hóa đọc hiểu &amp; viết test case</a:t>
+              <a:t>👤 Vũ Thị Mai Linh  •  🎯 AI QA Specialist  •  ⚡ Antigravity Native Plugin &amp; Google Workspace MCP</a:t>
             </a:r>
           </a:p>
         </p:txBody>
@@ -4000,9 +3541,9 @@
           <a:solidFill>
             <a:srgbClr val="FFFFFF"/>
           </a:solidFill>
-          <a:ln w="19050">
+          <a:ln w="12700">
             <a:solidFill>
-              <a:srgbClr val="CBD5E1"/>
+              <a:srgbClr val="E2E8F0"/>
             </a:solidFill>
           </a:ln>
         </p:spPr>
@@ -4153,9 +3694,9 @@
           <a:solidFill>
             <a:srgbClr val="FFFFFF"/>
           </a:solidFill>
-          <a:ln w="19050">
+          <a:ln w="12700">
             <a:solidFill>
-              <a:srgbClr val="CBD5E1"/>
+              <a:srgbClr val="E2E8F0"/>
             </a:solidFill>
           </a:ln>
         </p:spPr>
@@ -4306,9 +3847,9 @@
           <a:solidFill>
             <a:srgbClr val="FFFFFF"/>
           </a:solidFill>
-          <a:ln w="19050">
+          <a:ln w="12700">
             <a:solidFill>
-              <a:srgbClr val="CBD5E1"/>
+              <a:srgbClr val="E2E8F0"/>
             </a:solidFill>
           </a:ln>
         </p:spPr>
@@ -4621,9 +4162,9 @@
           <a:solidFill>
             <a:srgbClr val="FFFFFF"/>
           </a:solidFill>
-          <a:ln w="19050">
+          <a:ln w="12700">
             <a:solidFill>
-              <a:srgbClr val="1677FF"/>
+              <a:srgbClr val="E2E8F0"/>
             </a:solidFill>
           </a:ln>
         </p:spPr>
@@ -4774,9 +4315,9 @@
           <a:solidFill>
             <a:srgbClr val="FFFFFF"/>
           </a:solidFill>
-          <a:ln w="19050">
+          <a:ln w="12700">
             <a:solidFill>
-              <a:srgbClr val="0D9488"/>
+              <a:srgbClr val="E2E8F0"/>
             </a:solidFill>
           </a:ln>
         </p:spPr>
@@ -4927,9 +4468,9 @@
           <a:solidFill>
             <a:srgbClr val="FFFFFF"/>
           </a:solidFill>
-          <a:ln w="19050">
+          <a:ln w="12700">
             <a:solidFill>
-              <a:srgbClr val="16A34A"/>
+              <a:srgbClr val="E2E8F0"/>
             </a:solidFill>
           </a:ln>
         </p:spPr>
@@ -5242,9 +4783,9 @@
           <a:solidFill>
             <a:srgbClr val="FFFFFF"/>
           </a:solidFill>
-          <a:ln w="19050">
+          <a:ln w="12700">
             <a:solidFill>
-              <a:srgbClr val="1677FF"/>
+              <a:srgbClr val="E2E8F0"/>
             </a:solidFill>
           </a:ln>
         </p:spPr>
@@ -5359,9 +4900,9 @@
           <a:solidFill>
             <a:srgbClr val="FFFFFF"/>
           </a:solidFill>
-          <a:ln w="19050">
+          <a:ln w="12700">
             <a:solidFill>
-              <a:srgbClr val="0D9488"/>
+              <a:srgbClr val="E2E8F0"/>
             </a:solidFill>
           </a:ln>
         </p:spPr>
@@ -5476,9 +5017,9 @@
           <a:solidFill>
             <a:srgbClr val="FFFFFF"/>
           </a:solidFill>
-          <a:ln w="19050">
+          <a:ln w="12700">
             <a:solidFill>
-              <a:srgbClr val="16A34A"/>
+              <a:srgbClr val="E2E8F0"/>
             </a:solidFill>
           </a:ln>
         </p:spPr>
@@ -5593,9 +5134,9 @@
           <a:solidFill>
             <a:srgbClr val="E6F4FF"/>
           </a:solidFill>
-          <a:ln w="19050">
+          <a:ln w="12700">
             <a:solidFill>
-              <a:srgbClr val="1677FF"/>
+              <a:srgbClr val="E2E8F0"/>
             </a:solidFill>
           </a:ln>
         </p:spPr>
@@ -5821,9 +5362,9 @@
           <a:solidFill>
             <a:srgbClr val="FFFFFF"/>
           </a:solidFill>
-          <a:ln w="19050">
+          <a:ln w="12700">
             <a:solidFill>
-              <a:srgbClr val="1677FF"/>
+              <a:srgbClr val="E2E8F0"/>
             </a:solidFill>
           </a:ln>
         </p:spPr>
@@ -6016,9 +5557,9 @@
           <a:solidFill>
             <a:srgbClr val="FFFFFF"/>
           </a:solidFill>
-          <a:ln w="19050">
+          <a:ln w="12700">
             <a:solidFill>
-              <a:srgbClr val="7C3AED"/>
+              <a:srgbClr val="E2E8F0"/>
             </a:solidFill>
           </a:ln>
         </p:spPr>
@@ -6238,9 +5779,9 @@
           <a:solidFill>
             <a:srgbClr val="FFFFFF"/>
           </a:solidFill>
-          <a:ln w="19050">
+          <a:ln w="12700">
             <a:solidFill>
-              <a:srgbClr val="16A34A"/>
+              <a:srgbClr val="E2E8F0"/>
             </a:solidFill>
           </a:ln>
         </p:spPr>
@@ -6595,9 +6136,9 @@
           <a:solidFill>
             <a:srgbClr val="FFFFFF"/>
           </a:solidFill>
-          <a:ln w="19050">
+          <a:ln w="12700">
             <a:solidFill>
-              <a:srgbClr val="1677FF"/>
+              <a:srgbClr val="E2E8F0"/>
             </a:solidFill>
           </a:ln>
         </p:spPr>
@@ -6794,9 +6335,9 @@
           <a:solidFill>
             <a:srgbClr val="FFFFFF"/>
           </a:solidFill>
-          <a:ln w="19050">
+          <a:ln w="12700">
             <a:solidFill>
-              <a:srgbClr val="0D9488"/>
+              <a:srgbClr val="E2E8F0"/>
             </a:solidFill>
           </a:ln>
         </p:spPr>
@@ -6993,9 +6534,9 @@
           <a:solidFill>
             <a:srgbClr val="FFFFFF"/>
           </a:solidFill>
-          <a:ln w="19050">
+          <a:ln w="12700">
             <a:solidFill>
-              <a:srgbClr val="E11D48"/>
+              <a:srgbClr val="E2E8F0"/>
             </a:solidFill>
           </a:ln>
         </p:spPr>
@@ -7192,9 +6733,9 @@
           <a:solidFill>
             <a:srgbClr val="FFFFFF"/>
           </a:solidFill>
-          <a:ln w="19050">
+          <a:ln w="12700">
             <a:solidFill>
-              <a:srgbClr val="16A34A"/>
+              <a:srgbClr val="E2E8F0"/>
             </a:solidFill>
           </a:ln>
         </p:spPr>

</xml_diff>

<commit_message>
docs: rewrite slide 2 with accessible, non-technical language
</commit_message>
<xml_diff>
--- a/docs/QA_AI_Assistant_Interview_Presentation.pptx
+++ b/docs/QA_AI_Assistant_Interview_Presentation.pptx
@@ -5340,7 +5340,7 @@
               </a:defRPr>
             </a:pPr>
             <a:r>
-              <a:t>Cơ chế tự động hóa toàn diện từ lúc nhận tài liệu yêu cầu thô đến khi xuất ra bộ test suite hoàn chỉnh.</a:t>
+              <a:t>Quy trình tự động từ lúc nhận yêu cầu ban đầu đến khi xuất ra bảng kịch bản kiểm thử hoàn chỉnh, dễ hiểu và dùng được ngay.</a:t>
             </a:r>
           </a:p>
         </p:txBody>
@@ -5412,7 +5412,7 @@
               </a:defRPr>
             </a:pPr>
             <a:r>
-              <a:t>Tiếp Nhận &amp; Đọc Hiểu Spec</a:t>
+              <a:t>Tiếp Nhận &amp; Đọc Hiểu Yêu Cầu</a:t>
             </a:r>
           </a:p>
           <a:p>
@@ -5427,7 +5427,7 @@
               </a:defRPr>
             </a:pPr>
             <a:r>
-              <a:t>Xử lý đa dạng mọi nguồn tài liệu dự án</a:t>
+              <a:t>Đọc hiểu linh hoạt mọi dạng tài liệu dự án</a:t>
             </a:r>
           </a:p>
           <a:p>
@@ -5439,7 +5439,7 @@
               </a:defRPr>
             </a:pPr>
             <a:r>
-              <a:t>📄 User Story &amp; Acceptance Criteria:</a:t>
+              <a:t>📄 Yêu cầu tính năng &amp; mong muốn người dùng:</a:t>
             </a:r>
           </a:p>
           <a:p>
@@ -5454,7 +5454,7 @@
               </a:defRPr>
             </a:pPr>
             <a:r>
-              <a:t>Đọc hiểu bối cảnh người dùng, tiêu chí nghiệm thu còn sơ sài hoặc diễn đạt mơ hồ.</a:t>
+              <a:t>Đọc hiểu bối cảnh và tiêu chí nghiệm thu kể cả khi diễn đạt còn mơ hồ, thiếu ý.</a:t>
             </a:r>
           </a:p>
           <a:p>
@@ -5466,7 +5466,7 @@
               </a:defRPr>
             </a:pPr>
             <a:r>
-              <a:t>📑 Tài liệu BA / PRD Chi Tiết:</a:t>
+              <a:t>📑 Tài liệu nghiệp vụ chi tiết:</a:t>
             </a:r>
           </a:p>
           <a:p>
@@ -5481,7 +5481,7 @@
               </a:defRPr>
             </a:pPr>
             <a:r>
-              <a:t>Phân tích tài liệu nghiệp vụ dài, phức tạp nhiều phân hệ chức năng.</a:t>
+              <a:t>Phân tích mạch lạc tài liệu quy trình kinh doanh dài và phức tạp của dự án.</a:t>
             </a:r>
           </a:p>
           <a:p>
@@ -5493,7 +5493,7 @@
               </a:defRPr>
             </a:pPr>
             <a:r>
-              <a:t>⚙️ API Swagger / JSON Schema:</a:t>
+              <a:t>⚙️ Thông số kỹ thuật &amp; cổng dữ liệu:</a:t>
             </a:r>
           </a:p>
           <a:p>
@@ -5508,7 +5508,7 @@
               </a:defRPr>
             </a:pPr>
             <a:r>
-              <a:t>Đọc hiểu method HTTP, headers, request body, query params và response schema.</a:t>
+              <a:t>Tự động hiểu cấu trúc thông tin gửi đi và kết quả hệ thống cần trả về.</a:t>
             </a:r>
           </a:p>
           <a:p>
@@ -5520,7 +5520,7 @@
               </a:defRPr>
             </a:pPr>
             <a:r>
-              <a:t>🧠 Bộ nhớ góc nhìn (user_preferences):</a:t>
+              <a:t>🧠 Tự điều chỉnh cách hành văn:</a:t>
             </a:r>
           </a:p>
           <a:p>
@@ -5535,7 +5535,7 @@
               </a:defRPr>
             </a:pPr>
             <a:r>
-              <a:t>Tự động điều chỉnh giọng văn phân tích: Business (dễ hiểu) vs Technical (chuyên sâu).</a:t>
+              <a:t>Linh hoạt dùng từ ngữ đời sống dễ hiểu cho Nghiệp vụ hoặc chuyên sâu cho Kỹ thuật.</a:t>
             </a:r>
           </a:p>
         </p:txBody>
@@ -5592,7 +5592,7 @@
               </a:defRPr>
             </a:pPr>
             <a:r>
-              <a:t>⚙️ GIAI ĐOẠN 2: TÁC VỤ THỰC HIỆN</a:t>
+              <a:t>⚙️ GIAI ĐOẠN 2: TỰ ĐỘNG XỬ LÝ</a:t>
             </a:r>
           </a:p>
           <a:p>
@@ -5607,7 +5607,7 @@
               </a:defRPr>
             </a:pPr>
             <a:r>
-              <a:t>Phân Tích, Phản Biện &amp; Thiết Kế</a:t>
+              <a:t>Phân Tích &amp; Soạn Kịch Bản</a:t>
             </a:r>
           </a:p>
           <a:p>
@@ -5622,7 +5622,7 @@
               </a:defRPr>
             </a:pPr>
             <a:r>
-              <a:t>5 tác vụ AI chuyên sâu thay thế công việc thủ công</a:t>
+              <a:t>Chỉ ra điểm thiếu sót và dựng kịch bản kiểm tra toàn diện</a:t>
             </a:r>
           </a:p>
           <a:p>
@@ -5634,7 +5634,7 @@
               </a:defRPr>
             </a:pPr>
             <a:r>
-              <a:t>📋 Bóc tách 4 thành tố cốt lõi:</a:t>
+              <a:t>📋 Phân tách quy tắc &amp; luồng hoạt động:</a:t>
             </a:r>
           </a:p>
           <a:p>
@@ -5649,7 +5649,7 @@
               </a:defRPr>
             </a:pPr>
             <a:r>
-              <a:t>Tự động phân tách Rules, Boundary Limits, Exception Flows và User Journey.</a:t>
+              <a:t>Tự động chỉ ra quy tắc đúng, giới hạn số liệu, trường hợp phát sinh lỗi và luồng người dùng.</a:t>
             </a:r>
           </a:p>
           <a:p>
@@ -5661,7 +5661,7 @@
               </a:defRPr>
             </a:pPr>
             <a:r>
-              <a:t>❓ Soạn câu hỏi phản biện cho BA:</a:t>
+              <a:t>❓ Đặt câu hỏi làm rõ điểm chưa rõ ràng:</a:t>
             </a:r>
           </a:p>
           <a:p>
@@ -5676,7 +5676,7 @@
               </a:defRPr>
             </a:pPr>
             <a:r>
-              <a:t>Chỉ ra các điểm hở tài liệu, mâu thuẫn logic để chốt sớm với BA/PO.</a:t>
+              <a:t>Tìm ra các kẽ hở logic, trường hợp bỏ sót để đội ngũ chốt sớm với nhau trước khi làm.</a:t>
             </a:r>
           </a:p>
           <a:p>
@@ -5688,7 +5688,7 @@
               </a:defRPr>
             </a:pPr>
             <a:r>
-              <a:t>🔍 Quét 5 rủi ro kiến trúc sâu:</a:t>
+              <a:t>🔍 Cảnh báo sớm các lỗi ngầm khó phát hiện:</a:t>
             </a:r>
           </a:p>
           <a:p>
@@ -5703,7 +5703,7 @@
               </a:defRPr>
             </a:pPr>
             <a:r>
-              <a:t>Race condition (&lt;=50ms), Lost Update, Concurrency Deadlock, JWT Drift, Clock Drift.</a:t>
+              <a:t>Dự đoán nguy cơ lỗi khi nhiều người cùng thao tác một lúc, trùng lặp đơn hàng hoặc phiên đăng nhập hết hạn.</a:t>
             </a:r>
           </a:p>
           <a:p>
@@ -5715,7 +5715,7 @@
               </a:defRPr>
             </a:pPr>
             <a:r>
-              <a:t>🗄️ Đối chiếu 10 Bugs Ground Truth:</a:t>
+              <a:t>🗄️ Soi chiếu với các lỗi thực tế hay gặp:</a:t>
             </a:r>
           </a:p>
           <a:p>
@@ -5730,7 +5730,7 @@
               </a:defRPr>
             </a:pPr>
             <a:r>
-              <a:t>Gắn mã Defect ID tương đồng từ kho bug thực tế để neo chuẩn logic.</a:t>
+              <a:t>Dùng kho lỗi phổ biến ngoài đời thực để nhắc nhở và không bỏ sót tình huống kiểm tra.</a:t>
             </a:r>
           </a:p>
           <a:p>
@@ -5742,7 +5742,7 @@
               </a:defRPr>
             </a:pPr>
             <a:r>
-              <a:t>💎 3 Nguyên Tắc Vàng QA:</a:t>
+              <a:t>💎 Kịch bản chi tiết, rõ ràng từng bước:</a:t>
             </a:r>
           </a:p>
           <a:p>
@@ -5757,7 +5757,7 @@
               </a:defRPr>
             </a:pPr>
             <a:r>
-              <a:t>Tách bước độc lập (Disaggregation), Verify 3 tầng sâu (UI/API/DB), Gán Status NOT_RUN.</a:t>
+              <a:t>Tách nhỏ từng thao tác, đối soát kỹ giao diện người dùng, đường truyền dữ liệu và cơ sở dữ liệu thật.</a:t>
             </a:r>
           </a:p>
         </p:txBody>
@@ -5814,7 +5814,7 @@
               </a:defRPr>
             </a:pPr>
             <a:r>
-              <a:t>📤 GIAI ĐOẠN 3: ĐẦU RA BÀN GIAO</a:t>
+              <a:t>📤 GIAI ĐOẠN 3: BÀN GIAO KẾT QUẢ</a:t>
             </a:r>
           </a:p>
           <a:p>
@@ -5829,7 +5829,7 @@
               </a:defRPr>
             </a:pPr>
             <a:r>
-              <a:t>Sản Phẩm Bàn Giao Sạch 100%</a:t>
+              <a:t>Bảng Kịch Bản Hoàn Chỉnh</a:t>
             </a:r>
           </a:p>
           <a:p>
@@ -5844,7 +5844,7 @@
               </a:defRPr>
             </a:pPr>
             <a:r>
-              <a:t>Trực quan hóa Google Sheets &amp; Lưu trữ bền vững</a:t>
+              <a:t>Trình bày trực quan trên Google Sheets, dùng được ngay</a:t>
             </a:r>
           </a:p>
           <a:p>
@@ -5856,7 +5856,7 @@
               </a:defRPr>
             </a:pPr>
             <a:r>
-              <a:t>📊 Google Sheets Master Ant Design Blue:</a:t>
+              <a:t>📊 Bảng kịch bản trực quan trên Google Sheets:</a:t>
             </a:r>
           </a:p>
           <a:p>
@@ -5871,7 +5871,7 @@
               </a:defRPr>
             </a:pPr>
             <a:r>
-              <a:t>Tự động ghi nối tiếp vào 2 tab Requirements &amp; Test Cases, Header xanh #1677FF, freeze row 1.</a:t>
+              <a:t>Tự động lưu trữ vào bảng tính chuẩn mực, phân mục rõ ràng, chuyên nghiệp và dễ xem.</a:t>
             </a:r>
           </a:p>
           <a:p>
@@ -5883,7 +5883,7 @@
               </a:defRPr>
             </a:pPr>
             <a:r>
-              <a:t>🎯 Dropdown Status &amp; Conditional Format:</a:t>
+              <a:t>🎯 Menu chọn kết quả tiện lợi:</a:t>
             </a:r>
           </a:p>
           <a:p>
@@ -5898,7 +5898,7 @@
               </a:defRPr>
             </a:pPr>
             <a:r>
-              <a:t>Menu chọn nhanh PASS/FAIL/BLOCKED/NOT_RUN tự đổi màu tiện lợi cho Tester.</a:t>
+              <a:t>Cho phép Tester bấm chọn Đạt / Không đạt / Đang chờ, tự động đổi màu trực quan khi làm việc.</a:t>
             </a:r>
           </a:p>
           <a:p>
@@ -5910,7 +5910,7 @@
               </a:defRPr>
             </a:pPr>
             <a:r>
-              <a:t>💾 Local-First Append-Only:</a:t>
+              <a:t>💾 Tích lũy liên tục, không lo mất lịch sử:</a:t>
             </a:r>
           </a:p>
           <a:p>
@@ -5925,7 +5925,7 @@
               </a:defRPr>
             </a:pPr>
             <a:r>
-              <a:t>Lưu tích lũy vào file JSON cục bộ, bảo toàn 100% lịch sử các sprint trước, cấm reset.</a:t>
+              <a:t>Tự động lưu nối tiếp các đợt kiểm thử mới mà không làm mất dữ liệu của các kỳ trước.</a:t>
             </a:r>
           </a:p>
           <a:p>
@@ -5937,7 +5937,7 @@
               </a:defRPr>
             </a:pPr>
             <a:r>
-              <a:t>🤖 Sẵn sàng Playwright E2E Automation:</a:t>
+              <a:t>🤖 Sẵn sàng đưa vào kiểm thử tự động:</a:t>
             </a:r>
           </a:p>
           <a:p>
@@ -5952,7 +5952,7 @@
               </a:defRPr>
             </a:pPr>
             <a:r>
-              <a:t>Kịch bản đã chia nhỏ bước, code tự động hóa ngay mà không cần viết lại.</a:t>
+              <a:t>Các bước kiểm tra được viết gãy gọn, giúp đội ngũ có thể cài đặt cho máy chạy tự động ngay.</a:t>
             </a:r>
           </a:p>
         </p:txBody>

</xml_diff>